<commit_message>
Add new docs, update README, remove Office temp files
- Add Power Platform guides (weeks 1-4), CV files, DAX/SSIS updates
- Add .gitignore to prevent ~$ lock files and *.tmp from being tracked
- Remove all previously tracked Office lock/temp files

Co-Authored-By: Claude Sonnet 4.6 <noreply@anthropic.com>
</commit_message>
<xml_diff>
--- a/SSIS-SSAS/SSIS Essentials.pptx
+++ b/SSIS-SSAS/SSIS Essentials.pptx
@@ -483,7 +483,7 @@
           <a:p>
             <a:fld id="{8070E9B5-7476-4606-A034-210CC4B39A90}" type="datetimeFigureOut">
               <a:rPr lang="en-US" smtClean="0"/>
-              <a:t>3/27/2026</a:t>
+              <a:t>4/29/2026</a:t>
             </a:fld>
             <a:endParaRPr lang="en-US"/>
           </a:p>
@@ -683,7 +683,7 @@
           <a:p>
             <a:fld id="{8070E9B5-7476-4606-A034-210CC4B39A90}" type="datetimeFigureOut">
               <a:rPr lang="en-US" smtClean="0"/>
-              <a:t>3/27/2026</a:t>
+              <a:t>4/29/2026</a:t>
             </a:fld>
             <a:endParaRPr lang="en-US"/>
           </a:p>
@@ -893,7 +893,7 @@
           <a:p>
             <a:fld id="{8070E9B5-7476-4606-A034-210CC4B39A90}" type="datetimeFigureOut">
               <a:rPr lang="en-US" smtClean="0"/>
-              <a:t>3/27/2026</a:t>
+              <a:t>4/29/2026</a:t>
             </a:fld>
             <a:endParaRPr lang="en-US"/>
           </a:p>
@@ -1093,7 +1093,7 @@
           <a:p>
             <a:fld id="{8070E9B5-7476-4606-A034-210CC4B39A90}" type="datetimeFigureOut">
               <a:rPr lang="en-US" smtClean="0"/>
-              <a:t>3/27/2026</a:t>
+              <a:t>4/29/2026</a:t>
             </a:fld>
             <a:endParaRPr lang="en-US"/>
           </a:p>
@@ -1369,7 +1369,7 @@
           <a:p>
             <a:fld id="{8070E9B5-7476-4606-A034-210CC4B39A90}" type="datetimeFigureOut">
               <a:rPr lang="en-US" smtClean="0"/>
-              <a:t>3/27/2026</a:t>
+              <a:t>4/29/2026</a:t>
             </a:fld>
             <a:endParaRPr lang="en-US"/>
           </a:p>
@@ -1637,7 +1637,7 @@
           <a:p>
             <a:fld id="{8070E9B5-7476-4606-A034-210CC4B39A90}" type="datetimeFigureOut">
               <a:rPr lang="en-US" smtClean="0"/>
-              <a:t>3/27/2026</a:t>
+              <a:t>4/29/2026</a:t>
             </a:fld>
             <a:endParaRPr lang="en-US"/>
           </a:p>
@@ -2052,7 +2052,7 @@
           <a:p>
             <a:fld id="{8070E9B5-7476-4606-A034-210CC4B39A90}" type="datetimeFigureOut">
               <a:rPr lang="en-US" smtClean="0"/>
-              <a:t>3/27/2026</a:t>
+              <a:t>4/29/2026</a:t>
             </a:fld>
             <a:endParaRPr lang="en-US"/>
           </a:p>
@@ -2194,7 +2194,7 @@
           <a:p>
             <a:fld id="{8070E9B5-7476-4606-A034-210CC4B39A90}" type="datetimeFigureOut">
               <a:rPr lang="en-US" smtClean="0"/>
-              <a:t>3/27/2026</a:t>
+              <a:t>4/29/2026</a:t>
             </a:fld>
             <a:endParaRPr lang="en-US"/>
           </a:p>
@@ -2307,7 +2307,7 @@
           <a:p>
             <a:fld id="{8070E9B5-7476-4606-A034-210CC4B39A90}" type="datetimeFigureOut">
               <a:rPr lang="en-US" smtClean="0"/>
-              <a:t>3/27/2026</a:t>
+              <a:t>4/29/2026</a:t>
             </a:fld>
             <a:endParaRPr lang="en-US"/>
           </a:p>
@@ -2620,7 +2620,7 @@
           <a:p>
             <a:fld id="{8070E9B5-7476-4606-A034-210CC4B39A90}" type="datetimeFigureOut">
               <a:rPr lang="en-US" smtClean="0"/>
-              <a:t>3/27/2026</a:t>
+              <a:t>4/29/2026</a:t>
             </a:fld>
             <a:endParaRPr lang="en-US"/>
           </a:p>
@@ -2909,7 +2909,7 @@
           <a:p>
             <a:fld id="{8070E9B5-7476-4606-A034-210CC4B39A90}" type="datetimeFigureOut">
               <a:rPr lang="en-US" smtClean="0"/>
-              <a:t>3/27/2026</a:t>
+              <a:t>4/29/2026</a:t>
             </a:fld>
             <a:endParaRPr lang="en-US"/>
           </a:p>
@@ -3152,7 +3152,7 @@
           <a:p>
             <a:fld id="{8070E9B5-7476-4606-A034-210CC4B39A90}" type="datetimeFigureOut">
               <a:rPr lang="en-US" smtClean="0"/>
-              <a:t>3/27/2026</a:t>
+              <a:t>4/29/2026</a:t>
             </a:fld>
             <a:endParaRPr lang="en-US"/>
           </a:p>
@@ -4344,7 +4344,7 @@
               <a:rPr lang="nl-BE" sz="1400" dirty="0">
                 <a:sym typeface="Wingdings" panose="05000000000000000000" pitchFamily="2" charset="2"/>
               </a:rPr>
-              <a:t> This use to copy , move , delete in a directory, after processing a file , you can move or delete it using this task</a:t>
+              <a:t> This use to copy , move , delete in a directory, after processing a file , you can move or delete files it using this task</a:t>
             </a:r>
             <a:endParaRPr lang="nl-BE" sz="1400" dirty="0"/>
           </a:p>
@@ -5506,7 +5506,7 @@
             </a:r>
             <a:r>
               <a:rPr lang="nl-BE" sz="1300" dirty="0"/>
-              <a:t>to move (redect the bad record to a </a:t>
+              <a:t>to move (redirect the bad record to a </a:t>
             </a:r>
             <a:r>
               <a:rPr lang="nl-BE" sz="1300" b="1" i="1" dirty="0"/>
@@ -5748,15 +5748,7 @@
           <a:p>
             <a:r>
               <a:rPr lang="en-US" sz="1300" i="1" dirty="0"/>
-              <a:t>Find / connect to the </a:t>
-            </a:r>
-            <a:r>
-              <a:rPr lang="en-US" sz="1300" i="1" dirty="0" err="1"/>
-              <a:t>tqrget</a:t>
-            </a:r>
-            <a:r>
-              <a:rPr lang="en-US" sz="1300" i="1" dirty="0"/>
-              <a:t> server where SSISDB has been created (DSV, TEST, ACC, PROD)</a:t>
+              <a:t>Find / connect to the target server where SSISDB has been created (DSV, TEST, ACC, PROD)</a:t>
             </a:r>
           </a:p>
           <a:p>
@@ -5924,7 +5916,7 @@
             </a:pPr>
             <a:r>
               <a:rPr lang="nl-BE" sz="1300" i="1" dirty="0"/>
-              <a:t>First identify the table that will be use as DataSource and create views on top of those.</a:t>
+              <a:t>First identify the tables (combination of tables)that will be use as DataSource and create views on top of those.</a:t>
             </a:r>
           </a:p>
           <a:p>
@@ -5956,7 +5948,15 @@
             </a:r>
             <a:r>
               <a:rPr lang="nl-BE" sz="1300" i="1" dirty="0"/>
-              <a:t>), create some measure , calculated colulns (based on business needes)</a:t>
+              <a:t>), create some measure , calculated colulns (based on </a:t>
+            </a:r>
+            <a:r>
+              <a:rPr lang="nl-BE" sz="1300" i="1"/>
+              <a:t>business needs</a:t>
+            </a:r>
+            <a:r>
+              <a:rPr lang="nl-BE" sz="1300" i="1" dirty="0"/>
+              <a:t>)</a:t>
             </a:r>
           </a:p>
           <a:p>

</xml_diff>